<commit_message>
Add 11-segment pitch variant; keep tree edge labels off the edges
build_pitch.py takes an optional argument: without it, it builds the
7-segment pitch; with "11", pitch_3min_11seg.pptx. The 11-segment
variant shows the six questions as a native diagram with segment chips
(B1-E2 split A-G further, coloured by 2024 attendance) next to the
2024 table (segment AUC 0.81), and maps each of the 11 segments to a
channel and an effect range.

Both variants now give segment C the pre-booked slot (+10 to +19 p. b.),
consistent with the impact calculation, which applies that range to
B and C.

The decision tree in vzp_segmentation_final.ipynb places the yes/no
labels beside the edges: to the right of vertical edges, above
horizontal ones, and perpendicular to slanted ones on the outer side
(offsets in screen points, as the axes are not equally scaled). Leaf
counts use Czech number formatting. The segmentation deck uses the new
tree image.

Co-Authored-By: Claude Opus 5.5 <noreply@anthropic.com>
</commit_message>
<xml_diff>
--- a/docs/vzp_pitch/pitch_3min.pptx
+++ b/docs/vzp_pitch/pitch_3min.pptx
@@ -732,7 +732,7 @@
           <a:lstStyle/>
           <a:p>
             <a:r>
-              <a:t>35 s. Jak je používáme? Každý segment dostane kanál, kterým ho zastihneme, a opatření, které podle studií funguje. Prvním pozvaným pevný termín místo otevřené pozvánky: v anglických studiích plus deset až devatenáct bodů. Ženám u gynekologa nebo praktika oslovení přes lékaře. Nedávno vyšetřeným dopis neposíláme vůbec. Z e-commerce přinášíme způsob práce: automatické kaskády zpráv, A/B test s kontrolní skupinou u každé změny a měření skutečného přírůstku, ne kliknutí.</a:t>
+              <a:t>35 s. Jak je používáme? Každý segment dostane kanál, kterým ho zastihneme, a opatření, které podle studií funguje. Prvním pozvaným a vypadlým pevný termín místo otevřené pozvánky: v anglických studiích plus deset až devatenáct bodů. Ženám u gynekologa nebo praktika oslovení přes lékaře. Nedávno vyšetřeným dopis neposíláme vůbec. Z e-commerce přinášíme způsob práce: automatické kaskády zpráv, A/B test s kontrolní skupinou u každé změny a měření skutečného přírůstku, ne kliknutí.</a:t>
             </a:r>
           </a:p>
         </p:txBody>
@@ -4844,7 +4844,7 @@
                             <a:srgbClr val="230F3C"/>
                           </a:solidFill>
                         </a:rPr>
-                        <a:t>dřívější připomínka s termínem (25.–36. měsíc)</a:t>
+                        <a:t>pevný termín dřív: ve 25.–36. měsíci místo po 3–5 letech</a:t>
                       </a:r>
                     </a:p>
                   </a:txBody>
@@ -4861,12 +4861,12 @@
                     <a:p>
                       <a:pPr algn="r"/>
                       <a:r>
-                        <a:rPr sz="1050" b="0">
+                        <a:rPr sz="1050" b="1">
                           <a:solidFill>
                             <a:srgbClr val="230F3C"/>
                           </a:solidFill>
                         </a:rPr>
-                        <a:t>+2 až +6</a:t>
+                        <a:t>+10 až +19</a:t>
                       </a:r>
                     </a:p>
                   </a:txBody>

</xml_diff>